<commit_message>
Fix as-of date to 24 Jul 2026 and harmonize subsystem numbers across all deliverables + pptx
- Correct the as-of/report date to 24 Juli 2026 (a parallel commit had set
  26 Jul; today is 24 Jul). Event dates (chamber/repo 23 Jul, etc.) unchanged.
- Harmonize subsystem progress to the corrected dashboard values across
  graph.json, entities.md, Knowledge_Graph, and the PowerPoint:
  Integrasi 92->68 (AI on-device pending), AI 52->55 (dataset consistent),
  Chamber 35->55 (control system working).
- graph.json: as_of 2026-07-24; LoRa reframed 'per-hop (disiasati mesh)'.
- CLAUDE.md: theme rule updated to blue/charcoal; date 24 Jul.
- pptx GLD_V2_Progress_Report_Jul2026: date + subsystem values aligned.
- timeline.md: chamber milestone dated 23 Jul; 24 Jul as-of.

Co-Authored-By: Claude Opus 4.8 <noreply@anthropic.com>
Claude-Session: https://claude.ai/code/session_01VMi9nKMva2BmPWwMMpgkrT
</commit_message>
<xml_diff>
--- a/GLD_V2_Progress_Report_Jul2026.pptx
+++ b/GLD_V2_Progress_Report_Jul2026.pptx
@@ -5466,7 +5466,7 @@
               </a:defRPr>
             </a:pPr>
             <a:r>
-              <a:t>Posisi proyek per 26 Juli 2026</a:t>
+              <a:t>Posisi proyek per 24 Juli 2026</a:t>
             </a:r>
           </a:p>
         </p:txBody>
@@ -9036,7 +9036,7 @@
               </a:defRPr>
             </a:pPr>
             <a:r>
-              <a:t>92%</a:t>
+              <a:t>68%</a:t>
             </a:r>
           </a:p>
         </p:txBody>
@@ -9668,7 +9668,7 @@
               </a:defRPr>
             </a:pPr>
             <a:r>
-              <a:t>52%</a:t>
+              <a:t>55%</a:t>
             </a:r>
           </a:p>
         </p:txBody>
@@ -10142,7 +10142,7 @@
               </a:defRPr>
             </a:pPr>
             <a:r>
-              <a:t>35%</a:t>
+              <a:t>55%</a:t>
             </a:r>
           </a:p>
         </p:txBody>

</xml_diff>